<commit_message>
mejoras en los comentarios
</commit_message>
<xml_diff>
--- a/PresentacionEDA.pptx
+++ b/PresentacionEDA.pptx
@@ -5945,6 +5945,13 @@
             <a:schemeClr val="lt1"/>
           </a:fontRef>
         </p:style>
+        <p:txBody>
+          <a:bodyPr/>
+          <a:lstStyle/>
+          <a:p>
+            <a:endParaRPr lang="es-ES"/>
+          </a:p>
+        </p:txBody>
       </p:sp>
       <p:sp>
         <p:nvSpPr>
@@ -7251,6 +7258,13 @@
             <a:schemeClr val="lt1"/>
           </a:fontRef>
         </p:style>
+        <p:txBody>
+          <a:bodyPr/>
+          <a:lstStyle/>
+          <a:p>
+            <a:endParaRPr lang="es-ES"/>
+          </a:p>
+        </p:txBody>
       </p:sp>
       <p:sp>
         <p:nvSpPr>
@@ -8828,7 +8842,7 @@
             </a:r>
             <a:r>
               <a:rPr lang="es-ES" dirty="0"/>
-              <a:t> salen a un precio inferior al 50% de su valor de mercado"</a:t>
+              <a:t> salen con descuento sobre su tasación inferior al 50%"</a:t>
             </a:r>
             <a:endParaRPr lang="es-ES" sz="2400" dirty="0"/>
           </a:p>
@@ -11134,7 +11148,7 @@
                   <a:schemeClr val="accent1"/>
                 </a:solidFill>
               </a:rPr>
-              <a:t>“El precio de subasta siempre está por debajo del valor de mercado”</a:t>
+              <a:t>“El precio de subasta siempre está por debajo del valor de la tasación”</a:t>
             </a:r>
           </a:p>
         </p:txBody>
@@ -12095,8 +12109,8 @@
         </p:nvSpPr>
         <p:spPr>
           <a:xfrm>
-            <a:off x="1109417" y="1520431"/>
-            <a:ext cx="3592286" cy="1569660"/>
+            <a:off x="676529" y="1542821"/>
+            <a:ext cx="5547023" cy="1569660"/>
           </a:xfrm>
           <a:prstGeom prst="rect">
             <a:avLst/>
@@ -12116,7 +12130,7 @@
                   <a:schemeClr val="accent1"/>
                 </a:solidFill>
               </a:rPr>
-              <a:t>El 89.4 % de subastas tributarias salen por debajo del 50% de su tasación </a:t>
+              <a:t>El 89.4 % de las subastas analizadas tienen un descuento sobre tasación inferior al 50% , salen a más del 50% de su valor de mercado</a:t>
             </a:r>
           </a:p>
         </p:txBody>
@@ -12136,7 +12150,7 @@
         <p:spPr>
           <a:xfrm>
             <a:off x="860439" y="3740838"/>
-            <a:ext cx="4510161" cy="1477328"/>
+            <a:ext cx="4510161" cy="1200329"/>
           </a:xfrm>
           <a:prstGeom prst="rect">
             <a:avLst/>
@@ -12166,16 +12180,6 @@
             <a:r>
               <a:rPr lang="es-ES" dirty="0"/>
               <a:t>Depósito siempre = 5% del valor subasta</a:t>
-            </a:r>
-          </a:p>
-          <a:p>
-            <a:pPr marL="285750" indent="-285750">
-              <a:buFont typeface="Wingdings" panose="05000000000000000000" pitchFamily="2" charset="2"/>
-              <a:buChar char="q"/>
-            </a:pPr>
-            <a:r>
-              <a:rPr lang="es-ES" dirty="0"/>
-              <a:t>Descuento independiente del valor</a:t>
             </a:r>
           </a:p>
           <a:p>

</xml_diff>